<commit_message>
Lighter district and Uttar Pradesh pages, report contents lists visible, Uttar Pradesh deck rebuilt
Co-Authored-By: Claude Opus 5.5 <noreply@anthropic.com>
Claude-Session: https://claude.ai/code/session_012JjD5mhtvLxzAXoZHMZYE5
</commit_message>
<xml_diff>
--- a/reports/uttar-pradesh-sir-2026-deck.pptx
+++ b/reports/uttar-pradesh-sir-2026-deck.pptx
@@ -2097,7 +2097,7 @@
                 <a:ea typeface="Calibri" pitchFamily="34" charset="-122"/>
                 <a:cs typeface="Calibri" pitchFamily="34" charset="-120"/>
               </a:rPr>
-              <a:t>Spread over the constituencies of each district, the names left off were larger than the 2022 winning margin in 377 of the 403 seats. That shows the names left off were large enough to decide those seats, and does not show that they did.</a:t>
+              <a:t>No count by constituency was published. If each district's names left off are shared out over its seats by their electors, the share is larger than the 2022 winning margin in 377 of the 403 seats. This estimates how many seats the names left off could have decided. It cannot say which seats, or that any result changed.</a:t>
             </a:r>
             <a:endParaRPr lang="en-US" sz="1300" dirty="0"/>
           </a:p>
@@ -2237,7 +2237,7 @@
       </p:sp>
       <p:pic>
         <p:nvPicPr>
-          <p:cNvPr id="4" name="Image 0" descr="/tmp/pack-BpyxFC/up-uttarpradesh-9.png">    </p:cNvPr>
+          <p:cNvPr id="4" name="Image 0" descr="/tmp/pack-dnioOA/up-uttarpradesh-9.png">    </p:cNvPr>
           <p:cNvPicPr>
             <a:picLocks noChangeAspect="1"/>
           </p:cNvPicPr>
@@ -2410,7 +2410,7 @@
       </p:sp>
       <p:pic>
         <p:nvPicPr>
-          <p:cNvPr id="4" name="Image 0" descr="/tmp/pack-BpyxFC/up-uttarpradesh-10.png">    </p:cNvPr>
+          <p:cNvPr id="4" name="Image 0" descr="/tmp/pack-dnioOA/up-uttarpradesh-10.png">    </p:cNvPr>
           <p:cNvPicPr>
             <a:picLocks noChangeAspect="1"/>
           </p:cNvPicPr>
@@ -2736,7 +2736,7 @@
       </p:sp>
       <p:pic>
         <p:nvPicPr>
-          <p:cNvPr id="4" name="Image 0" descr="/tmp/pack-BpyxFC/up-uttarpradesh-1.png">    </p:cNvPr>
+          <p:cNvPr id="4" name="Image 0" descr="/tmp/pack-dnioOA/up-uttarpradesh-1.png">    </p:cNvPr>
           <p:cNvPicPr>
             <a:picLocks noChangeAspect="1"/>
           </p:cNvPicPr>
@@ -2909,7 +2909,7 @@
       </p:sp>
       <p:pic>
         <p:nvPicPr>
-          <p:cNvPr id="4" name="Image 0" descr="/tmp/pack-BpyxFC/up-uttarpradesh-2.png">    </p:cNvPr>
+          <p:cNvPr id="4" name="Image 0" descr="/tmp/pack-dnioOA/up-uttarpradesh-2.png">    </p:cNvPr>
           <p:cNvPicPr>
             <a:picLocks noChangeAspect="1"/>
           </p:cNvPicPr>
@@ -3082,7 +3082,7 @@
       </p:sp>
       <p:pic>
         <p:nvPicPr>
-          <p:cNvPr id="4" name="Image 0" descr="/tmp/pack-BpyxFC/up-uttarpradesh-3.png">    </p:cNvPr>
+          <p:cNvPr id="4" name="Image 0" descr="/tmp/pack-dnioOA/up-uttarpradesh-3.png">    </p:cNvPr>
           <p:cNvPicPr>
             <a:picLocks noChangeAspect="1"/>
           </p:cNvPicPr>
@@ -3255,7 +3255,7 @@
       </p:sp>
       <p:pic>
         <p:nvPicPr>
-          <p:cNvPr id="4" name="Image 0" descr="/tmp/pack-BpyxFC/up-uttarpradesh-4.png">    </p:cNvPr>
+          <p:cNvPr id="4" name="Image 0" descr="/tmp/pack-dnioOA/up-uttarpradesh-4.png">    </p:cNvPr>
           <p:cNvPicPr>
             <a:picLocks noChangeAspect="1"/>
           </p:cNvPicPr>
@@ -3467,7 +3467,7 @@
       </p:sp>
       <p:pic>
         <p:nvPicPr>
-          <p:cNvPr id="4" name="Image 0" descr="/tmp/pack-BpyxFC/up-uttarpradesh-5.png">    </p:cNvPr>
+          <p:cNvPr id="4" name="Image 0" descr="/tmp/pack-dnioOA/up-uttarpradesh-5.png">    </p:cNvPr>
           <p:cNvPicPr>
             <a:picLocks noChangeAspect="1"/>
           </p:cNvPicPr>
@@ -3640,7 +3640,7 @@
       </p:sp>
       <p:pic>
         <p:nvPicPr>
-          <p:cNvPr id="4" name="Image 0" descr="/tmp/pack-BpyxFC/up-uttarpradesh-6.png">    </p:cNvPr>
+          <p:cNvPr id="4" name="Image 0" descr="/tmp/pack-dnioOA/up-uttarpradesh-6.png">    </p:cNvPr>
           <p:cNvPicPr>
             <a:picLocks noChangeAspect="1"/>
           </p:cNvPicPr>
@@ -3813,7 +3813,7 @@
       </p:sp>
       <p:pic>
         <p:nvPicPr>
-          <p:cNvPr id="4" name="Image 0" descr="/tmp/pack-BpyxFC/up-uttarpradesh-7.png">    </p:cNvPr>
+          <p:cNvPr id="4" name="Image 0" descr="/tmp/pack-dnioOA/up-uttarpradesh-7.png">    </p:cNvPr>
           <p:cNvPicPr>
             <a:picLocks noChangeAspect="1"/>
           </p:cNvPicPr>
@@ -3986,7 +3986,7 @@
       </p:sp>
       <p:pic>
         <p:nvPicPr>
-          <p:cNvPr id="4" name="Image 0" descr="/tmp/pack-BpyxFC/up-uttarpradesh-8.png">    </p:cNvPr>
+          <p:cNvPr id="4" name="Image 0" descr="/tmp/pack-dnioOA/up-uttarpradesh-8.png">    </p:cNvPr>
           <p:cNvPicPr>
             <a:picLocks noChangeAspect="1"/>
           </p:cNvPicPr>
@@ -4000,8 +4000,8 @@
         </p:blipFill>
         <p:spPr>
           <a:xfrm>
-            <a:off x="2459769" y="1691640"/>
-            <a:ext cx="7272158" cy="4617720"/>
+            <a:off x="2451864" y="1691640"/>
+            <a:ext cx="7287967" cy="4617720"/>
           </a:xfrm>
           <a:prstGeom prst="rect">
             <a:avLst/>

</xml_diff>

<commit_message>
Lighter district and Uttar Pradesh pages, report contents lists, Uttar Pradesh deck (#204)
- District pages load data/india/factors/<state>.json (about 10 KB) in
place of factors.json (227 KB). Figures are identical to the live pages
(checked on Agra and Kolkata North).
- The Uttar Pradesh page reads disputes_counts.json and the new
help_counts.json in place of disputes.json and help.json (about 480 KB).
Counts are unchanged (28 and 4).
- Report contents lists were hidden by the margin-list rule; now
excluded from it and visible at 390 and 1280.
- Uttar Pradesh report and deck rebuilt with page_pack.mjs, carrying the
corrected margin takeaway.

All checks pass.

---
_Generated by [Claude
Code](https://claude.ai/code/session_012JjD5mhtvLxzAXoZHMZYE5)_

Co-authored-by: Claude <noreply@anthropic.com>
</commit_message>
<xml_diff>
--- a/reports/uttar-pradesh-sir-2026-deck.pptx
+++ b/reports/uttar-pradesh-sir-2026-deck.pptx
@@ -2097,7 +2097,7 @@
                 <a:ea typeface="Calibri" pitchFamily="34" charset="-122"/>
                 <a:cs typeface="Calibri" pitchFamily="34" charset="-120"/>
               </a:rPr>
-              <a:t>Spread over the constituencies of each district, the names left off were larger than the 2022 winning margin in 377 of the 403 seats. That shows the names left off were large enough to decide those seats, and does not show that they did.</a:t>
+              <a:t>No count by constituency was published. If each district's names left off are shared out over its seats by their electors, the share is larger than the 2022 winning margin in 377 of the 403 seats. This estimates how many seats the names left off could have decided. It cannot say which seats, or that any result changed.</a:t>
             </a:r>
             <a:endParaRPr lang="en-US" sz="1300" dirty="0"/>
           </a:p>
@@ -2237,7 +2237,7 @@
       </p:sp>
       <p:pic>
         <p:nvPicPr>
-          <p:cNvPr id="4" name="Image 0" descr="/tmp/pack-BpyxFC/up-uttarpradesh-9.png">    </p:cNvPr>
+          <p:cNvPr id="4" name="Image 0" descr="/tmp/pack-dnioOA/up-uttarpradesh-9.png">    </p:cNvPr>
           <p:cNvPicPr>
             <a:picLocks noChangeAspect="1"/>
           </p:cNvPicPr>
@@ -2410,7 +2410,7 @@
       </p:sp>
       <p:pic>
         <p:nvPicPr>
-          <p:cNvPr id="4" name="Image 0" descr="/tmp/pack-BpyxFC/up-uttarpradesh-10.png">    </p:cNvPr>
+          <p:cNvPr id="4" name="Image 0" descr="/tmp/pack-dnioOA/up-uttarpradesh-10.png">    </p:cNvPr>
           <p:cNvPicPr>
             <a:picLocks noChangeAspect="1"/>
           </p:cNvPicPr>
@@ -2736,7 +2736,7 @@
       </p:sp>
       <p:pic>
         <p:nvPicPr>
-          <p:cNvPr id="4" name="Image 0" descr="/tmp/pack-BpyxFC/up-uttarpradesh-1.png">    </p:cNvPr>
+          <p:cNvPr id="4" name="Image 0" descr="/tmp/pack-dnioOA/up-uttarpradesh-1.png">    </p:cNvPr>
           <p:cNvPicPr>
             <a:picLocks noChangeAspect="1"/>
           </p:cNvPicPr>
@@ -2909,7 +2909,7 @@
       </p:sp>
       <p:pic>
         <p:nvPicPr>
-          <p:cNvPr id="4" name="Image 0" descr="/tmp/pack-BpyxFC/up-uttarpradesh-2.png">    </p:cNvPr>
+          <p:cNvPr id="4" name="Image 0" descr="/tmp/pack-dnioOA/up-uttarpradesh-2.png">    </p:cNvPr>
           <p:cNvPicPr>
             <a:picLocks noChangeAspect="1"/>
           </p:cNvPicPr>
@@ -3082,7 +3082,7 @@
       </p:sp>
       <p:pic>
         <p:nvPicPr>
-          <p:cNvPr id="4" name="Image 0" descr="/tmp/pack-BpyxFC/up-uttarpradesh-3.png">    </p:cNvPr>
+          <p:cNvPr id="4" name="Image 0" descr="/tmp/pack-dnioOA/up-uttarpradesh-3.png">    </p:cNvPr>
           <p:cNvPicPr>
             <a:picLocks noChangeAspect="1"/>
           </p:cNvPicPr>
@@ -3255,7 +3255,7 @@
       </p:sp>
       <p:pic>
         <p:nvPicPr>
-          <p:cNvPr id="4" name="Image 0" descr="/tmp/pack-BpyxFC/up-uttarpradesh-4.png">    </p:cNvPr>
+          <p:cNvPr id="4" name="Image 0" descr="/tmp/pack-dnioOA/up-uttarpradesh-4.png">    </p:cNvPr>
           <p:cNvPicPr>
             <a:picLocks noChangeAspect="1"/>
           </p:cNvPicPr>
@@ -3467,7 +3467,7 @@
       </p:sp>
       <p:pic>
         <p:nvPicPr>
-          <p:cNvPr id="4" name="Image 0" descr="/tmp/pack-BpyxFC/up-uttarpradesh-5.png">    </p:cNvPr>
+          <p:cNvPr id="4" name="Image 0" descr="/tmp/pack-dnioOA/up-uttarpradesh-5.png">    </p:cNvPr>
           <p:cNvPicPr>
             <a:picLocks noChangeAspect="1"/>
           </p:cNvPicPr>
@@ -3640,7 +3640,7 @@
       </p:sp>
       <p:pic>
         <p:nvPicPr>
-          <p:cNvPr id="4" name="Image 0" descr="/tmp/pack-BpyxFC/up-uttarpradesh-6.png">    </p:cNvPr>
+          <p:cNvPr id="4" name="Image 0" descr="/tmp/pack-dnioOA/up-uttarpradesh-6.png">    </p:cNvPr>
           <p:cNvPicPr>
             <a:picLocks noChangeAspect="1"/>
           </p:cNvPicPr>
@@ -3813,7 +3813,7 @@
       </p:sp>
       <p:pic>
         <p:nvPicPr>
-          <p:cNvPr id="4" name="Image 0" descr="/tmp/pack-BpyxFC/up-uttarpradesh-7.png">    </p:cNvPr>
+          <p:cNvPr id="4" name="Image 0" descr="/tmp/pack-dnioOA/up-uttarpradesh-7.png">    </p:cNvPr>
           <p:cNvPicPr>
             <a:picLocks noChangeAspect="1"/>
           </p:cNvPicPr>
@@ -3986,7 +3986,7 @@
       </p:sp>
       <p:pic>
         <p:nvPicPr>
-          <p:cNvPr id="4" name="Image 0" descr="/tmp/pack-BpyxFC/up-uttarpradesh-8.png">    </p:cNvPr>
+          <p:cNvPr id="4" name="Image 0" descr="/tmp/pack-dnioOA/up-uttarpradesh-8.png">    </p:cNvPr>
           <p:cNvPicPr>
             <a:picLocks noChangeAspect="1"/>
           </p:cNvPicPr>
@@ -4000,8 +4000,8 @@
         </p:blipFill>
         <p:spPr>
           <a:xfrm>
-            <a:off x="2459769" y="1691640"/>
-            <a:ext cx="7272158" cy="4617720"/>
+            <a:off x="2451864" y="1691640"/>
+            <a:ext cx="7287967" cy="4617720"/>
           </a:xfrm>
           <a:prstGeom prst="rect">
             <a:avLst/>

</xml_diff>